<commit_message>
Pioneer address: pioneer-hive.vercel.app everywhere, new QR code and deck
Co-Authored-By: Claude Fable 5.1 <noreply@anthropic.com>
</commit_message>
<xml_diff>
--- a/deck/Pioneer.pptx
+++ b/deck/Pioneer.pptx
@@ -861,7 +861,7 @@
           <a:lstStyle/>
           <a:p>
             <a:r>
-              <a:t>Let's watch it fly. [Demo, 40 seconds: open mayday-alpha-eight.vercel.app/live, press "Launch both".] On the left, a real agent flying alone is refused, one undocumented rule at a time. On the right, the agent asks the hive first, gets the proven route, and its payout goes through. [Read out both "Refused calls" counters, left then right, then return to the deck.]</a:t>
+              <a:t>Let's watch it fly. [Demo, 40 seconds: open pioneer-hive.vercel.app/live, press "Launch both".] On the left, a real agent flying alone is refused, one undocumented rule at a time. On the right, the agent asks the hive first, gets the proven route, and its payout goes through. [Read out both "Refused calls" counters, left then right, then return to the deck.]</a:t>
             </a:r>
           </a:p>
         </p:txBody>
@@ -4862,7 +4862,7 @@
         <p:spPr>
           <a:xfrm>
             <a:off x="685800" y="3017520"/>
-            <a:ext cx="6251496" cy="530352"/>
+            <a:ext cx="5326709" cy="530352"/>
           </a:xfrm>
           <a:prstGeom prst="roundRect">
             <a:avLst>
@@ -4893,7 +4893,7 @@
         <p:spPr>
           <a:xfrm>
             <a:off x="960120" y="3017520"/>
-            <a:ext cx="5702856" cy="530352"/>
+            <a:ext cx="4778069" cy="530352"/>
           </a:xfrm>
           <a:prstGeom prst="rect">
             <a:avLst/>
@@ -4918,7 +4918,7 @@
                 </a:solidFill>
                 <a:latin typeface="Menlo"/>
               </a:rPr>
-              <a:t>https://mayday-alpha-eight.vercel.app</a:t>
+              <a:t>https://pioneer-hive.vercel.app</a:t>
             </a:r>
           </a:p>
         </p:txBody>
@@ -5320,7 +5320,7 @@
                 </a:solidFill>
                 <a:latin typeface="Menlo"/>
               </a:rPr>
-              <a:t>mayday-alpha-eight.vercel.app</a:t>
+              <a:t>pioneer-hive.vercel.app</a:t>
             </a:r>
           </a:p>
         </p:txBody>
@@ -5950,7 +5950,7 @@
                 </a:solidFill>
                 <a:latin typeface="Menlo"/>
               </a:rPr>
-              <a:t>mayday-alpha-eight.vercel.app</a:t>
+              <a:t>pioneer-hive.vercel.app</a:t>
             </a:r>
           </a:p>
         </p:txBody>
@@ -7468,7 +7468,7 @@
                 </a:solidFill>
                 <a:latin typeface="Menlo"/>
               </a:rPr>
-              <a:t>mayday-alpha-eight.vercel.app</a:t>
+              <a:t>pioneer-hive.vercel.app</a:t>
             </a:r>
           </a:p>
         </p:txBody>
@@ -9233,7 +9233,7 @@
                 </a:solidFill>
                 <a:latin typeface="Menlo"/>
               </a:rPr>
-              <a:t>mayday-alpha-eight.vercel.app</a:t>
+              <a:t>pioneer-hive.vercel.app</a:t>
             </a:r>
           </a:p>
         </p:txBody>
@@ -9697,7 +9697,7 @@
         <p:spPr>
           <a:xfrm>
             <a:off x="685800" y="4069080"/>
-            <a:ext cx="8421014" cy="822960"/>
+            <a:ext cx="7064044" cy="822960"/>
           </a:xfrm>
           <a:prstGeom prst="roundRect">
             <a:avLst>
@@ -9728,7 +9728,7 @@
         <p:spPr>
           <a:xfrm>
             <a:off x="1051560" y="4069080"/>
-            <a:ext cx="7689494" cy="822960"/>
+            <a:ext cx="6332524" cy="822960"/>
           </a:xfrm>
           <a:prstGeom prst="rect">
             <a:avLst/>
@@ -9753,7 +9753,7 @@
                 </a:solidFill>
                 <a:latin typeface="Helvetica Neue"/>
               </a:rPr>
-              <a:t>mayday-alpha-eight.vercel.app/live</a:t>
+              <a:t>pioneer-hive.vercel.app/live</a:t>
             </a:r>
           </a:p>
         </p:txBody>
@@ -10365,7 +10365,7 @@
                 </a:solidFill>
                 <a:latin typeface="Menlo"/>
               </a:rPr>
-              <a:t>mayday-alpha-eight.vercel.app</a:t>
+              <a:t>pioneer-hive.vercel.app</a:t>
             </a:r>
           </a:p>
         </p:txBody>
@@ -11805,7 +11805,7 @@
                 </a:solidFill>
                 <a:latin typeface="Menlo"/>
               </a:rPr>
-              <a:t>mayday-alpha-eight.vercel.app</a:t>
+              <a:t>pioneer-hive.vercel.app</a:t>
             </a:r>
           </a:p>
         </p:txBody>
@@ -13690,7 +13690,7 @@
                 </a:solidFill>
                 <a:latin typeface="Menlo"/>
               </a:rPr>
-              <a:t>mayday-alpha-eight.vercel.app</a:t>
+              <a:t>pioneer-hive.vercel.app</a:t>
             </a:r>
           </a:p>
         </p:txBody>
@@ -15107,7 +15107,7 @@
                 </a:solidFill>
                 <a:latin typeface="Menlo"/>
               </a:rPr>
-              <a:t>mayday-alpha-eight.vercel.app</a:t>
+              <a:t>pioneer-hive.vercel.app</a:t>
             </a:r>
           </a:p>
         </p:txBody>

</xml_diff>